<commit_message>
fixed page number in pptx
</commit_message>
<xml_diff>
--- a/Data_Cleaning/Presenttion PPT.pptx
+++ b/Data_Cleaning/Presenttion PPT.pptx
@@ -4134,7 +4134,7 @@
             <a:pPr algn="ctr"/>
             <a:r>
               <a:rPr lang="en-IN" dirty="0"/>
-              <a:t>16/17</a:t>
+              <a:t>10/11</a:t>
             </a:r>
           </a:p>
         </p:txBody>
@@ -9136,7 +9136,7 @@
             <a:pPr algn="ctr"/>
             <a:r>
               <a:rPr lang="en-IN" dirty="0"/>
-              <a:t>3/17</a:t>
+              <a:t>2/11</a:t>
             </a:r>
           </a:p>
         </p:txBody>
@@ -11024,7 +11024,7 @@
             <a:pPr algn="ctr"/>
             <a:r>
               <a:rPr lang="en-IN" dirty="0"/>
-              <a:t>2/17</a:t>
+              <a:t>3/11</a:t>
             </a:r>
           </a:p>
         </p:txBody>
@@ -13665,7 +13665,7 @@
             <a:pPr algn="ctr"/>
             <a:r>
               <a:rPr lang="en-IN" dirty="0"/>
-              <a:t>4/17</a:t>
+              <a:t>4/11</a:t>
             </a:r>
           </a:p>
         </p:txBody>
@@ -15901,7 +15901,7 @@
             <a:pPr algn="ctr"/>
             <a:r>
               <a:rPr lang="en-IN" dirty="0"/>
-              <a:t>13/17</a:t>
+              <a:t>5/11</a:t>
             </a:r>
           </a:p>
         </p:txBody>
@@ -16377,7 +16377,7 @@
             <a:pPr algn="ctr"/>
             <a:r>
               <a:rPr lang="en-IN" dirty="0"/>
-              <a:t>6/17</a:t>
+              <a:t>6/11</a:t>
             </a:r>
           </a:p>
         </p:txBody>
@@ -20094,7 +20094,7 @@
             <a:pPr algn="ctr"/>
             <a:r>
               <a:rPr lang="en-IN" dirty="0"/>
-              <a:t>8/17</a:t>
+              <a:t>7/11</a:t>
             </a:r>
           </a:p>
         </p:txBody>
@@ -23544,7 +23544,7 @@
             <a:pPr algn="ctr"/>
             <a:r>
               <a:rPr lang="en-IN" dirty="0"/>
-              <a:t>12/17</a:t>
+              <a:t>9/11</a:t>
             </a:r>
           </a:p>
         </p:txBody>
@@ -26025,7 +26025,7 @@
             <a:pPr algn="ctr"/>
             <a:r>
               <a:rPr lang="en-IN" dirty="0"/>
-              <a:t>14/17</a:t>
+              <a:t>9/11</a:t>
             </a:r>
           </a:p>
         </p:txBody>

</xml_diff>